<commit_message>
Add author details to working paper slides
</commit_message>
<xml_diff>
--- a/files/DesignPatent_15min_Slides.pptx
+++ b/files/DesignPatent_15min_Slides.pptx
@@ -1917,13 +1917,51 @@
       </p:sp>
       <p:sp>
         <p:nvSpPr>
-          <p:cNvPr id="6" name="Shape 4"/>
-          <p:cNvSpPr/>
-          <p:nvPr/>
-        </p:nvSpPr>
-        <p:spPr>
-          <a:xfrm>
-            <a:off x="658368" y="3584448"/>
+          <p:cNvPr id="6" name="Text 4"/>
+          <p:cNvSpPr/>
+          <p:nvPr/>
+        </p:nvSpPr>
+        <p:spPr>
+          <a:xfrm>
+            <a:off x="658368" y="3346704"/>
+            <a:ext cx="10607040" cy="274320"/>
+          </a:xfrm>
+          <a:prstGeom prst="rect">
+            <a:avLst/>
+          </a:prstGeom>
+          <a:noFill/>
+          <a:ln/>
+        </p:spPr>
+        <p:txBody>
+          <a:bodyPr wrap="square" lIns="0" tIns="0" rIns="0" bIns="0" rtlCol="0" anchor="ctr">
+            <a:normAutofit/>
+          </a:bodyPr>
+          <a:lstStyle/>
+          <a:p>
+            <a:pPr indent="0" marL="0">
+              <a:buNone/>
+            </a:pPr>
+            <a:r>
+              <a:rPr lang="en-US" sz="1250" dirty="0">
+                <a:solidFill>
+                  <a:srgbClr val="5E6470"/>
+                </a:solidFill>
+              </a:rPr>
+              <a:t>Department of Statistics, National Taipei University  ·  hcchuang@gm.ntpu.edu.tw</a:t>
+            </a:r>
+            <a:endParaRPr lang="en-US" sz="1250" dirty="0"/>
+          </a:p>
+        </p:txBody>
+      </p:sp>
+      <p:sp>
+        <p:nvSpPr>
+          <p:cNvPr id="7" name="Shape 5"/>
+          <p:cNvSpPr/>
+          <p:nvPr/>
+        </p:nvSpPr>
+        <p:spPr>
+          <a:xfrm>
+            <a:off x="658368" y="3803904"/>
             <a:ext cx="1828800" cy="0"/>
           </a:xfrm>
           <a:prstGeom prst="line">
@@ -1940,14 +1978,14 @@
       </p:sp>
       <p:sp>
         <p:nvSpPr>
-          <p:cNvPr id="7" name="Text 5"/>
-          <p:cNvSpPr/>
-          <p:nvPr/>
-        </p:nvSpPr>
-        <p:spPr>
-          <a:xfrm>
-            <a:off x="658368" y="4023360"/>
-            <a:ext cx="8961120" cy="1097280"/>
+          <p:cNvPr id="8" name="Text 6"/>
+          <p:cNvSpPr/>
+          <p:nvPr/>
+        </p:nvSpPr>
+        <p:spPr>
+          <a:xfrm>
+            <a:off x="658368" y="4151376"/>
+            <a:ext cx="8961120" cy="987552"/>
           </a:xfrm>
           <a:prstGeom prst="rect">
             <a:avLst/>
@@ -1978,7 +2016,7 @@
       </p:sp>
       <p:sp>
         <p:nvSpPr>
-          <p:cNvPr id="8" name="Text 6"/>
+          <p:cNvPr id="9" name="Text 7"/>
           <p:cNvSpPr/>
           <p:nvPr/>
         </p:nvSpPr>
@@ -2165,9 +2203,50 @@
           </a:p>
         </p:txBody>
       </p:sp>
+      <p:sp>
+        <p:nvSpPr>
+          <p:cNvPr id="4" name="Text 2"/>
+          <p:cNvSpPr/>
+          <p:nvPr/>
+        </p:nvSpPr>
+        <p:spPr>
+          <a:xfrm>
+            <a:off x="3749040" y="6254496"/>
+            <a:ext cx="7772400" cy="164592"/>
+          </a:xfrm>
+          <a:prstGeom prst="rect">
+            <a:avLst/>
+          </a:prstGeom>
+          <a:noFill/>
+          <a:ln/>
+        </p:spPr>
+        <p:txBody>
+          <a:bodyPr wrap="square" lIns="0" tIns="0" rIns="0" bIns="0" rtlCol="0" anchor="ctr">
+            <a:normAutofit/>
+          </a:bodyPr>
+          <a:lstStyle/>
+          <a:p>
+            <a:pPr algn="r" indent="0" marL="0">
+              <a:buNone/>
+            </a:pPr>
+            <a:r>
+              <a:rPr lang="en-US" sz="730" b="1" spc="35" kern="0" dirty="0">
+                <a:solidFill>
+                  <a:srgbClr val="5E6470"/>
+                </a:solidFill>
+                <a:latin typeface="Arial" pitchFamily="34" charset="0"/>
+                <a:ea typeface="Arial" pitchFamily="34" charset="-122"/>
+                <a:cs typeface="Arial" pitchFamily="34" charset="-120"/>
+              </a:rPr>
+              <a:t>DESIGN PATENT SIMILARITY WITH ARCFACE METRIC LEARNING  ·  HUI-CHING CHUANG  ·  YUEH-HENG WU</a:t>
+            </a:r>
+            <a:endParaRPr lang="en-US" sz="730" dirty="0"/>
+          </a:p>
+        </p:txBody>
+      </p:sp>
       <p:pic>
         <p:nvPicPr>
-          <p:cNvPr id="4" name="Image 0" descr="C:\Dropbox\Apps\Overleaf\ACM Conference Proceedings Primary Article Template\figure\Compare_D0807117_6766.png">    </p:cNvPr>
+          <p:cNvPr id="5" name="Image 0" descr="C:\Dropbox\Apps\Overleaf\ACM Conference Proceedings Primary Article Template\figure\Compare_D0807117_6766.png">    </p:cNvPr>
           <p:cNvPicPr>
             <a:picLocks noChangeAspect="1"/>
           </p:cNvPicPr>
@@ -2191,7 +2270,7 @@
       </p:pic>
       <p:sp>
         <p:nvSpPr>
-          <p:cNvPr id="5" name="Shape 2"/>
+          <p:cNvPr id="6" name="Shape 3"/>
           <p:cNvSpPr/>
           <p:nvPr/>
         </p:nvSpPr>
@@ -2218,7 +2297,7 @@
       </p:sp>
       <p:sp>
         <p:nvSpPr>
-          <p:cNvPr id="6" name="Shape 3"/>
+          <p:cNvPr id="7" name="Shape 4"/>
           <p:cNvSpPr/>
           <p:nvPr/>
         </p:nvSpPr>
@@ -2245,7 +2324,7 @@
       </p:sp>
       <p:sp>
         <p:nvSpPr>
-          <p:cNvPr id="7" name="Shape 4"/>
+          <p:cNvPr id="8" name="Shape 5"/>
           <p:cNvSpPr/>
           <p:nvPr/>
         </p:nvSpPr>
@@ -2270,7 +2349,7 @@
       </p:sp>
       <p:sp>
         <p:nvSpPr>
-          <p:cNvPr id="8" name="Text 5"/>
+          <p:cNvPr id="9" name="Text 6"/>
           <p:cNvSpPr/>
           <p:nvPr/>
         </p:nvSpPr>
@@ -2300,7 +2379,7 @@
                   <a:srgbClr val="111111"/>
                 </a:solidFill>
               </a:rPr>
-              <a:t>The retrieval target</a:t>
+              <a:t>The retrieval challenge</a:t>
             </a:r>
             <a:endParaRPr lang="en-US" sz="1400" dirty="0"/>
           </a:p>
@@ -2308,7 +2387,7 @@
       </p:sp>
       <p:sp>
         <p:nvSpPr>
-          <p:cNvPr id="9" name="Text 6"/>
+          <p:cNvPr id="10" name="Text 7"/>
           <p:cNvSpPr/>
           <p:nvPr/>
         </p:nvSpPr>
@@ -2338,7 +2417,7 @@
                   <a:srgbClr val="5E6470"/>
                 </a:solidFill>
               </a:rPr>
-              <a:t>Multiple views and minor drawing changes can belong to the same patented design.</a:t>
+              <a:t>Multiple views can depict one design, while category similarity is too coarse for prior-art search.</a:t>
             </a:r>
             <a:endParaRPr lang="en-US" sz="1150" dirty="0"/>
           </a:p>
@@ -2346,7 +2425,7 @@
       </p:sp>
       <p:sp>
         <p:nvSpPr>
-          <p:cNvPr id="10" name="Shape 7"/>
+          <p:cNvPr id="11" name="Shape 8"/>
           <p:cNvSpPr/>
           <p:nvPr/>
         </p:nvSpPr>
@@ -2373,7 +2452,7 @@
       </p:sp>
       <p:sp>
         <p:nvSpPr>
-          <p:cNvPr id="11" name="Shape 8"/>
+          <p:cNvPr id="12" name="Shape 9"/>
           <p:cNvSpPr/>
           <p:nvPr/>
         </p:nvSpPr>
@@ -2398,7 +2477,7 @@
       </p:sp>
       <p:sp>
         <p:nvSpPr>
-          <p:cNvPr id="12" name="Text 9"/>
+          <p:cNvPr id="13" name="Text 10"/>
           <p:cNvSpPr/>
           <p:nvPr/>
         </p:nvSpPr>
@@ -2428,7 +2507,7 @@
                   <a:srgbClr val="111111"/>
                 </a:solidFill>
               </a:rPr>
-              <a:t>The failure mode</a:t>
+              <a:t>The research question</a:t>
             </a:r>
             <a:endParaRPr lang="en-US" sz="1400" dirty="0"/>
           </a:p>
@@ -2436,7 +2515,7 @@
       </p:sp>
       <p:sp>
         <p:nvSpPr>
-          <p:cNvPr id="13" name="Text 10"/>
+          <p:cNvPr id="14" name="Text 11"/>
           <p:cNvSpPr/>
           <p:nvPr/>
         </p:nvSpPr>
@@ -2466,7 +2545,7 @@
                   <a:srgbClr val="5E6470"/>
                 </a:solidFill>
               </a:rPr>
-              <a:t>Category similarity is too coarse: two chairs can be legally and visually distinct.</a:t>
+              <a:t>Can metric learning organize drawings around patent identity at national scale?</a:t>
             </a:r>
             <a:endParaRPr lang="en-US" sz="1150" dirty="0"/>
           </a:p>
@@ -2474,7 +2553,7 @@
       </p:sp>
       <p:sp>
         <p:nvSpPr>
-          <p:cNvPr id="14" name="Shape 11"/>
+          <p:cNvPr id="15" name="Shape 12"/>
           <p:cNvSpPr/>
           <p:nvPr/>
         </p:nvSpPr>
@@ -2501,7 +2580,7 @@
       </p:sp>
       <p:sp>
         <p:nvSpPr>
-          <p:cNvPr id="15" name="Shape 12"/>
+          <p:cNvPr id="16" name="Shape 13"/>
           <p:cNvSpPr/>
           <p:nvPr/>
         </p:nvSpPr>
@@ -2526,7 +2605,7 @@
       </p:sp>
       <p:sp>
         <p:nvSpPr>
-          <p:cNvPr id="16" name="Text 13"/>
+          <p:cNvPr id="17" name="Text 14"/>
           <p:cNvSpPr/>
           <p:nvPr/>
         </p:nvSpPr>
@@ -2556,7 +2635,7 @@
                   <a:srgbClr val="111111"/>
                 </a:solidFill>
               </a:rPr>
-              <a:t>The research question</a:t>
+              <a:t>Experimental results</a:t>
             </a:r>
             <a:endParaRPr lang="en-US" sz="1400" dirty="0"/>
           </a:p>
@@ -2564,7 +2643,7 @@
       </p:sp>
       <p:sp>
         <p:nvSpPr>
-          <p:cNvPr id="17" name="Text 14"/>
+          <p:cNvPr id="18" name="Text 15"/>
           <p:cNvSpPr/>
           <p:nvPr/>
         </p:nvSpPr>
@@ -2594,7 +2673,7 @@
                   <a:srgbClr val="5E6470"/>
                 </a:solidFill>
               </a:rPr>
-              <a:t>Can metric learning organize drawings around patent identity at national scale?</a:t>
+              <a:t>Best mAP: 0.8193 Standard / 0.6493 Extended. Acc@1: 0.9312 / 0.8088.</a:t>
             </a:r>
             <a:endParaRPr lang="en-US" sz="1150" dirty="0"/>
           </a:p>
@@ -2602,7 +2681,7 @@
       </p:sp>
       <p:sp>
         <p:nvSpPr>
-          <p:cNvPr id="18" name="Text 15"/>
+          <p:cNvPr id="19" name="Text 16"/>
           <p:cNvSpPr/>
           <p:nvPr/>
         </p:nvSpPr>
@@ -2796,7 +2875,48 @@
       </p:sp>
       <p:sp>
         <p:nvSpPr>
-          <p:cNvPr id="4" name="Shape 2"/>
+          <p:cNvPr id="4" name="Text 2"/>
+          <p:cNvSpPr/>
+          <p:nvPr/>
+        </p:nvSpPr>
+        <p:spPr>
+          <a:xfrm>
+            <a:off x="3749040" y="6254496"/>
+            <a:ext cx="7772400" cy="164592"/>
+          </a:xfrm>
+          <a:prstGeom prst="rect">
+            <a:avLst/>
+          </a:prstGeom>
+          <a:noFill/>
+          <a:ln/>
+        </p:spPr>
+        <p:txBody>
+          <a:bodyPr wrap="square" lIns="0" tIns="0" rIns="0" bIns="0" rtlCol="0" anchor="ctr">
+            <a:normAutofit/>
+          </a:bodyPr>
+          <a:lstStyle/>
+          <a:p>
+            <a:pPr algn="r" indent="0" marL="0">
+              <a:buNone/>
+            </a:pPr>
+            <a:r>
+              <a:rPr lang="en-US" sz="730" b="1" spc="35" kern="0" dirty="0">
+                <a:solidFill>
+                  <a:srgbClr val="5E6470"/>
+                </a:solidFill>
+                <a:latin typeface="Arial" pitchFamily="34" charset="0"/>
+                <a:ea typeface="Arial" pitchFamily="34" charset="-122"/>
+                <a:cs typeface="Arial" pitchFamily="34" charset="-120"/>
+              </a:rPr>
+              <a:t>DESIGN PATENT SIMILARITY WITH ARCFACE METRIC LEARNING  ·  HUI-CHING CHUANG  ·  YUEH-HENG WU</a:t>
+            </a:r>
+            <a:endParaRPr lang="en-US" sz="730" dirty="0"/>
+          </a:p>
+        </p:txBody>
+      </p:sp>
+      <p:sp>
+        <p:nvSpPr>
+          <p:cNvPr id="5" name="Shape 3"/>
           <p:cNvSpPr/>
           <p:nvPr/>
         </p:nvSpPr>
@@ -2823,7 +2943,7 @@
       </p:sp>
       <p:sp>
         <p:nvSpPr>
-          <p:cNvPr id="5" name="Shape 3"/>
+          <p:cNvPr id="6" name="Shape 4"/>
           <p:cNvSpPr/>
           <p:nvPr/>
         </p:nvSpPr>
@@ -2848,7 +2968,7 @@
       </p:sp>
       <p:sp>
         <p:nvSpPr>
-          <p:cNvPr id="6" name="Text 4"/>
+          <p:cNvPr id="7" name="Text 5"/>
           <p:cNvSpPr/>
           <p:nvPr/>
         </p:nvSpPr>
@@ -2886,7 +3006,7 @@
       </p:sp>
       <p:sp>
         <p:nvSpPr>
-          <p:cNvPr id="7" name="Text 5"/>
+          <p:cNvPr id="8" name="Text 6"/>
           <p:cNvSpPr/>
           <p:nvPr/>
         </p:nvSpPr>
@@ -2924,7 +3044,7 @@
       </p:sp>
       <p:sp>
         <p:nvSpPr>
-          <p:cNvPr id="8" name="Shape 6"/>
+          <p:cNvPr id="9" name="Shape 7"/>
           <p:cNvSpPr/>
           <p:nvPr/>
         </p:nvSpPr>
@@ -2951,7 +3071,7 @@
       </p:sp>
       <p:sp>
         <p:nvSpPr>
-          <p:cNvPr id="9" name="Shape 7"/>
+          <p:cNvPr id="10" name="Shape 8"/>
           <p:cNvSpPr/>
           <p:nvPr/>
         </p:nvSpPr>
@@ -2976,7 +3096,7 @@
       </p:sp>
       <p:sp>
         <p:nvSpPr>
-          <p:cNvPr id="10" name="Text 8"/>
+          <p:cNvPr id="11" name="Text 9"/>
           <p:cNvSpPr/>
           <p:nvPr/>
         </p:nvSpPr>
@@ -3014,7 +3134,7 @@
       </p:sp>
       <p:sp>
         <p:nvSpPr>
-          <p:cNvPr id="11" name="Text 9"/>
+          <p:cNvPr id="12" name="Text 10"/>
           <p:cNvSpPr/>
           <p:nvPr/>
         </p:nvSpPr>
@@ -3052,7 +3172,7 @@
       </p:sp>
       <p:sp>
         <p:nvSpPr>
-          <p:cNvPr id="12" name="Shape 10"/>
+          <p:cNvPr id="13" name="Shape 11"/>
           <p:cNvSpPr/>
           <p:nvPr/>
         </p:nvSpPr>
@@ -3079,7 +3199,7 @@
       </p:sp>
       <p:sp>
         <p:nvSpPr>
-          <p:cNvPr id="13" name="Shape 11"/>
+          <p:cNvPr id="14" name="Shape 12"/>
           <p:cNvSpPr/>
           <p:nvPr/>
         </p:nvSpPr>
@@ -3104,7 +3224,7 @@
       </p:sp>
       <p:sp>
         <p:nvSpPr>
-          <p:cNvPr id="14" name="Text 12"/>
+          <p:cNvPr id="15" name="Text 13"/>
           <p:cNvSpPr/>
           <p:nvPr/>
         </p:nvSpPr>
@@ -3142,7 +3262,7 @@
       </p:sp>
       <p:sp>
         <p:nvSpPr>
-          <p:cNvPr id="15" name="Text 13"/>
+          <p:cNvPr id="16" name="Text 14"/>
           <p:cNvSpPr/>
           <p:nvPr/>
         </p:nvSpPr>
@@ -3180,7 +3300,7 @@
       </p:sp>
       <p:sp>
         <p:nvSpPr>
-          <p:cNvPr id="16" name="Shape 14"/>
+          <p:cNvPr id="17" name="Shape 15"/>
           <p:cNvSpPr/>
           <p:nvPr/>
         </p:nvSpPr>
@@ -3207,7 +3327,7 @@
       </p:sp>
       <p:sp>
         <p:nvSpPr>
-          <p:cNvPr id="17" name="Shape 15"/>
+          <p:cNvPr id="18" name="Shape 16"/>
           <p:cNvSpPr/>
           <p:nvPr/>
         </p:nvSpPr>
@@ -3232,7 +3352,7 @@
       </p:sp>
       <p:sp>
         <p:nvSpPr>
-          <p:cNvPr id="18" name="Text 16"/>
+          <p:cNvPr id="19" name="Text 17"/>
           <p:cNvSpPr/>
           <p:nvPr/>
         </p:nvSpPr>
@@ -3270,7 +3390,7 @@
       </p:sp>
       <p:sp>
         <p:nvSpPr>
-          <p:cNvPr id="19" name="Text 17"/>
+          <p:cNvPr id="20" name="Text 18"/>
           <p:cNvSpPr/>
           <p:nvPr/>
         </p:nvSpPr>
@@ -3308,7 +3428,7 @@
       </p:sp>
       <p:sp>
         <p:nvSpPr>
-          <p:cNvPr id="20" name="Text 18"/>
+          <p:cNvPr id="21" name="Text 19"/>
           <p:cNvSpPr/>
           <p:nvPr/>
         </p:nvSpPr>
@@ -3344,7 +3464,7 @@
       </p:sp>
       <p:sp>
         <p:nvSpPr>
-          <p:cNvPr id="21" name="Shape 19"/>
+          <p:cNvPr id="22" name="Shape 20"/>
           <p:cNvSpPr/>
           <p:nvPr/>
         </p:nvSpPr>
@@ -3369,7 +3489,7 @@
       </p:sp>
       <p:sp>
         <p:nvSpPr>
-          <p:cNvPr id="22" name="Shape 20"/>
+          <p:cNvPr id="23" name="Shape 21"/>
           <p:cNvSpPr/>
           <p:nvPr/>
         </p:nvSpPr>
@@ -3394,7 +3514,7 @@
       </p:sp>
       <p:sp>
         <p:nvSpPr>
-          <p:cNvPr id="23" name="Shape 21"/>
+          <p:cNvPr id="24" name="Shape 22"/>
           <p:cNvSpPr/>
           <p:nvPr/>
         </p:nvSpPr>
@@ -3419,7 +3539,7 @@
       </p:sp>
       <p:sp>
         <p:nvSpPr>
-          <p:cNvPr id="24" name="Text 22"/>
+          <p:cNvPr id="25" name="Text 23"/>
           <p:cNvSpPr/>
           <p:nvPr/>
         </p:nvSpPr>
@@ -3455,7 +3575,7 @@
       </p:sp>
       <p:sp>
         <p:nvSpPr>
-          <p:cNvPr id="25" name="Text 23"/>
+          <p:cNvPr id="26" name="Text 24"/>
           <p:cNvSpPr/>
           <p:nvPr/>
         </p:nvSpPr>
@@ -3493,7 +3613,7 @@
       </p:sp>
       <p:sp>
         <p:nvSpPr>
-          <p:cNvPr id="26" name="Text 24"/>
+          <p:cNvPr id="27" name="Text 25"/>
           <p:cNvSpPr/>
           <p:nvPr/>
         </p:nvSpPr>
@@ -3531,7 +3651,7 @@
       </p:sp>
       <p:sp>
         <p:nvSpPr>
-          <p:cNvPr id="27" name="Text 25"/>
+          <p:cNvPr id="28" name="Text 26"/>
           <p:cNvSpPr/>
           <p:nvPr/>
         </p:nvSpPr>
@@ -3569,7 +3689,7 @@
       </p:sp>
       <p:sp>
         <p:nvSpPr>
-          <p:cNvPr id="28" name="Text 26"/>
+          <p:cNvPr id="29" name="Text 27"/>
           <p:cNvSpPr/>
           <p:nvPr/>
         </p:nvSpPr>
@@ -3763,7 +3883,48 @@
       </p:sp>
       <p:sp>
         <p:nvSpPr>
-          <p:cNvPr id="4" name="Shape 2"/>
+          <p:cNvPr id="4" name="Text 2"/>
+          <p:cNvSpPr/>
+          <p:nvPr/>
+        </p:nvSpPr>
+        <p:spPr>
+          <a:xfrm>
+            <a:off x="3749040" y="6254496"/>
+            <a:ext cx="7772400" cy="164592"/>
+          </a:xfrm>
+          <a:prstGeom prst="rect">
+            <a:avLst/>
+          </a:prstGeom>
+          <a:noFill/>
+          <a:ln/>
+        </p:spPr>
+        <p:txBody>
+          <a:bodyPr wrap="square" lIns="0" tIns="0" rIns="0" bIns="0" rtlCol="0" anchor="ctr">
+            <a:normAutofit/>
+          </a:bodyPr>
+          <a:lstStyle/>
+          <a:p>
+            <a:pPr algn="r" indent="0" marL="0">
+              <a:buNone/>
+            </a:pPr>
+            <a:r>
+              <a:rPr lang="en-US" sz="730" b="1" spc="35" kern="0" dirty="0">
+                <a:solidFill>
+                  <a:srgbClr val="5E6470"/>
+                </a:solidFill>
+                <a:latin typeface="Arial" pitchFamily="34" charset="0"/>
+                <a:ea typeface="Arial" pitchFamily="34" charset="-122"/>
+                <a:cs typeface="Arial" pitchFamily="34" charset="-120"/>
+              </a:rPr>
+              <a:t>DESIGN PATENT SIMILARITY WITH ARCFACE METRIC LEARNING  ·  HUI-CHING CHUANG  ·  YUEH-HENG WU</a:t>
+            </a:r>
+            <a:endParaRPr lang="en-US" sz="730" dirty="0"/>
+          </a:p>
+        </p:txBody>
+      </p:sp>
+      <p:sp>
+        <p:nvSpPr>
+          <p:cNvPr id="5" name="Shape 3"/>
           <p:cNvSpPr/>
           <p:nvPr/>
         </p:nvSpPr>
@@ -3788,7 +3949,7 @@
       </p:sp>
       <p:sp>
         <p:nvSpPr>
-          <p:cNvPr id="5" name="Shape 3"/>
+          <p:cNvPr id="6" name="Shape 4"/>
           <p:cNvSpPr/>
           <p:nvPr/>
         </p:nvSpPr>
@@ -3813,7 +3974,7 @@
       </p:sp>
       <p:sp>
         <p:nvSpPr>
-          <p:cNvPr id="6" name="Shape 4"/>
+          <p:cNvPr id="7" name="Shape 5"/>
           <p:cNvSpPr/>
           <p:nvPr/>
         </p:nvSpPr>
@@ -3838,7 +3999,7 @@
       </p:sp>
       <p:sp>
         <p:nvSpPr>
-          <p:cNvPr id="7" name="Shape 5"/>
+          <p:cNvPr id="8" name="Shape 6"/>
           <p:cNvSpPr/>
           <p:nvPr/>
         </p:nvSpPr>
@@ -3865,7 +4026,7 @@
       </p:sp>
       <p:sp>
         <p:nvSpPr>
-          <p:cNvPr id="8" name="Text 6"/>
+          <p:cNvPr id="9" name="Text 7"/>
           <p:cNvSpPr/>
           <p:nvPr/>
         </p:nvSpPr>
@@ -3903,7 +4064,7 @@
       </p:sp>
       <p:sp>
         <p:nvSpPr>
-          <p:cNvPr id="9" name="Text 7"/>
+          <p:cNvPr id="10" name="Text 8"/>
           <p:cNvSpPr/>
           <p:nvPr/>
         </p:nvSpPr>
@@ -3941,7 +4102,7 @@
       </p:sp>
       <p:sp>
         <p:nvSpPr>
-          <p:cNvPr id="10" name="Shape 8"/>
+          <p:cNvPr id="11" name="Shape 9"/>
           <p:cNvSpPr/>
           <p:nvPr/>
         </p:nvSpPr>
@@ -3968,7 +4129,7 @@
       </p:sp>
       <p:sp>
         <p:nvSpPr>
-          <p:cNvPr id="11" name="Text 9"/>
+          <p:cNvPr id="12" name="Text 10"/>
           <p:cNvSpPr/>
           <p:nvPr/>
         </p:nvSpPr>
@@ -4006,7 +4167,7 @@
       </p:sp>
       <p:sp>
         <p:nvSpPr>
-          <p:cNvPr id="12" name="Text 10"/>
+          <p:cNvPr id="13" name="Text 11"/>
           <p:cNvSpPr/>
           <p:nvPr/>
         </p:nvSpPr>
@@ -4044,7 +4205,7 @@
       </p:sp>
       <p:sp>
         <p:nvSpPr>
-          <p:cNvPr id="13" name="Shape 11"/>
+          <p:cNvPr id="14" name="Shape 12"/>
           <p:cNvSpPr/>
           <p:nvPr/>
         </p:nvSpPr>
@@ -4071,7 +4232,7 @@
       </p:sp>
       <p:sp>
         <p:nvSpPr>
-          <p:cNvPr id="14" name="Text 12"/>
+          <p:cNvPr id="15" name="Text 13"/>
           <p:cNvSpPr/>
           <p:nvPr/>
         </p:nvSpPr>
@@ -4109,7 +4270,7 @@
       </p:sp>
       <p:sp>
         <p:nvSpPr>
-          <p:cNvPr id="15" name="Text 13"/>
+          <p:cNvPr id="16" name="Text 14"/>
           <p:cNvSpPr/>
           <p:nvPr/>
         </p:nvSpPr>
@@ -4147,7 +4308,7 @@
       </p:sp>
       <p:sp>
         <p:nvSpPr>
-          <p:cNvPr id="16" name="Shape 14"/>
+          <p:cNvPr id="17" name="Shape 15"/>
           <p:cNvSpPr/>
           <p:nvPr/>
         </p:nvSpPr>
@@ -4174,7 +4335,7 @@
       </p:sp>
       <p:sp>
         <p:nvSpPr>
-          <p:cNvPr id="17" name="Text 15"/>
+          <p:cNvPr id="18" name="Text 16"/>
           <p:cNvSpPr/>
           <p:nvPr/>
         </p:nvSpPr>
@@ -4212,7 +4373,7 @@
       </p:sp>
       <p:sp>
         <p:nvSpPr>
-          <p:cNvPr id="18" name="Text 16"/>
+          <p:cNvPr id="19" name="Text 17"/>
           <p:cNvSpPr/>
           <p:nvPr/>
         </p:nvSpPr>
@@ -4264,7 +4425,7 @@
       </p:sp>
       <p:sp>
         <p:nvSpPr>
-          <p:cNvPr id="19" name="Shape 17"/>
+          <p:cNvPr id="20" name="Shape 18"/>
           <p:cNvSpPr/>
           <p:nvPr/>
         </p:nvSpPr>
@@ -4291,7 +4452,7 @@
       </p:sp>
       <p:sp>
         <p:nvSpPr>
-          <p:cNvPr id="20" name="Shape 18"/>
+          <p:cNvPr id="21" name="Shape 19"/>
           <p:cNvSpPr/>
           <p:nvPr/>
         </p:nvSpPr>
@@ -4316,7 +4477,7 @@
       </p:sp>
       <p:sp>
         <p:nvSpPr>
-          <p:cNvPr id="21" name="Text 19"/>
+          <p:cNvPr id="22" name="Text 20"/>
           <p:cNvSpPr/>
           <p:nvPr/>
         </p:nvSpPr>
@@ -4354,7 +4515,7 @@
       </p:sp>
       <p:sp>
         <p:nvSpPr>
-          <p:cNvPr id="22" name="Text 20"/>
+          <p:cNvPr id="23" name="Text 21"/>
           <p:cNvSpPr/>
           <p:nvPr/>
         </p:nvSpPr>
@@ -4392,7 +4553,7 @@
       </p:sp>
       <p:sp>
         <p:nvSpPr>
-          <p:cNvPr id="23" name="Shape 21"/>
+          <p:cNvPr id="24" name="Shape 22"/>
           <p:cNvSpPr/>
           <p:nvPr/>
         </p:nvSpPr>
@@ -4419,7 +4580,7 @@
       </p:sp>
       <p:sp>
         <p:nvSpPr>
-          <p:cNvPr id="24" name="Shape 22"/>
+          <p:cNvPr id="25" name="Shape 23"/>
           <p:cNvSpPr/>
           <p:nvPr/>
         </p:nvSpPr>
@@ -4444,7 +4605,7 @@
       </p:sp>
       <p:sp>
         <p:nvSpPr>
-          <p:cNvPr id="25" name="Text 23"/>
+          <p:cNvPr id="26" name="Text 24"/>
           <p:cNvSpPr/>
           <p:nvPr/>
         </p:nvSpPr>
@@ -4482,7 +4643,7 @@
       </p:sp>
       <p:sp>
         <p:nvSpPr>
-          <p:cNvPr id="26" name="Text 24"/>
+          <p:cNvPr id="27" name="Text 25"/>
           <p:cNvSpPr/>
           <p:nvPr/>
         </p:nvSpPr>
@@ -4520,7 +4681,7 @@
       </p:sp>
       <p:sp>
         <p:nvSpPr>
-          <p:cNvPr id="27" name="Text 25"/>
+          <p:cNvPr id="28" name="Text 26"/>
           <p:cNvSpPr/>
           <p:nvPr/>
         </p:nvSpPr>
@@ -4714,7 +4875,48 @@
       </p:sp>
       <p:sp>
         <p:nvSpPr>
-          <p:cNvPr id="4" name="Shape 2"/>
+          <p:cNvPr id="4" name="Text 2"/>
+          <p:cNvSpPr/>
+          <p:nvPr/>
+        </p:nvSpPr>
+        <p:spPr>
+          <a:xfrm>
+            <a:off x="3749040" y="6254496"/>
+            <a:ext cx="7772400" cy="164592"/>
+          </a:xfrm>
+          <a:prstGeom prst="rect">
+            <a:avLst/>
+          </a:prstGeom>
+          <a:noFill/>
+          <a:ln/>
+        </p:spPr>
+        <p:txBody>
+          <a:bodyPr wrap="square" lIns="0" tIns="0" rIns="0" bIns="0" rtlCol="0" anchor="ctr">
+            <a:normAutofit/>
+          </a:bodyPr>
+          <a:lstStyle/>
+          <a:p>
+            <a:pPr algn="r" indent="0" marL="0">
+              <a:buNone/>
+            </a:pPr>
+            <a:r>
+              <a:rPr lang="en-US" sz="730" b="1" spc="35" kern="0" dirty="0">
+                <a:solidFill>
+                  <a:srgbClr val="5E6470"/>
+                </a:solidFill>
+                <a:latin typeface="Arial" pitchFamily="34" charset="0"/>
+                <a:ea typeface="Arial" pitchFamily="34" charset="-122"/>
+                <a:cs typeface="Arial" pitchFamily="34" charset="-120"/>
+              </a:rPr>
+              <a:t>DESIGN PATENT SIMILARITY WITH ARCFACE METRIC LEARNING  ·  HUI-CHING CHUANG  ·  YUEH-HENG WU</a:t>
+            </a:r>
+            <a:endParaRPr lang="en-US" sz="730" dirty="0"/>
+          </a:p>
+        </p:txBody>
+      </p:sp>
+      <p:sp>
+        <p:nvSpPr>
+          <p:cNvPr id="5" name="Shape 3"/>
           <p:cNvSpPr/>
           <p:nvPr/>
         </p:nvSpPr>
@@ -4737,7 +4939,7 @@
       </p:sp>
       <p:sp>
         <p:nvSpPr>
-          <p:cNvPr id="5" name="Shape 3"/>
+          <p:cNvPr id="6" name="Shape 4"/>
           <p:cNvSpPr/>
           <p:nvPr/>
         </p:nvSpPr>
@@ -4760,7 +4962,7 @@
       </p:sp>
       <p:sp>
         <p:nvSpPr>
-          <p:cNvPr id="6" name="Text 4"/>
+          <p:cNvPr id="7" name="Text 5"/>
           <p:cNvSpPr/>
           <p:nvPr/>
         </p:nvSpPr>
@@ -4796,7 +4998,7 @@
       </p:sp>
       <p:sp>
         <p:nvSpPr>
-          <p:cNvPr id="7" name="Shape 5"/>
+          <p:cNvPr id="8" name="Shape 6"/>
           <p:cNvSpPr/>
           <p:nvPr/>
         </p:nvSpPr>
@@ -4819,7 +5021,7 @@
       </p:sp>
       <p:sp>
         <p:nvSpPr>
-          <p:cNvPr id="8" name="Text 6"/>
+          <p:cNvPr id="9" name="Text 7"/>
           <p:cNvSpPr/>
           <p:nvPr/>
         </p:nvSpPr>
@@ -4855,7 +5057,7 @@
       </p:sp>
       <p:sp>
         <p:nvSpPr>
-          <p:cNvPr id="9" name="Shape 7"/>
+          <p:cNvPr id="10" name="Shape 8"/>
           <p:cNvSpPr/>
           <p:nvPr/>
         </p:nvSpPr>
@@ -4878,7 +5080,7 @@
       </p:sp>
       <p:sp>
         <p:nvSpPr>
-          <p:cNvPr id="10" name="Text 8"/>
+          <p:cNvPr id="11" name="Text 9"/>
           <p:cNvSpPr/>
           <p:nvPr/>
         </p:nvSpPr>
@@ -4914,7 +5116,7 @@
       </p:sp>
       <p:sp>
         <p:nvSpPr>
-          <p:cNvPr id="11" name="Shape 9"/>
+          <p:cNvPr id="12" name="Shape 10"/>
           <p:cNvSpPr/>
           <p:nvPr/>
         </p:nvSpPr>
@@ -4937,7 +5139,7 @@
       </p:sp>
       <p:sp>
         <p:nvSpPr>
-          <p:cNvPr id="12" name="Text 10"/>
+          <p:cNvPr id="13" name="Text 11"/>
           <p:cNvSpPr/>
           <p:nvPr/>
         </p:nvSpPr>
@@ -4973,7 +5175,7 @@
       </p:sp>
       <p:sp>
         <p:nvSpPr>
-          <p:cNvPr id="13" name="Shape 11"/>
+          <p:cNvPr id="14" name="Shape 12"/>
           <p:cNvSpPr/>
           <p:nvPr/>
         </p:nvSpPr>
@@ -4996,7 +5198,7 @@
       </p:sp>
       <p:sp>
         <p:nvSpPr>
-          <p:cNvPr id="14" name="Text 12"/>
+          <p:cNvPr id="15" name="Text 13"/>
           <p:cNvSpPr/>
           <p:nvPr/>
         </p:nvSpPr>
@@ -5032,7 +5234,7 @@
       </p:sp>
       <p:sp>
         <p:nvSpPr>
-          <p:cNvPr id="15" name="Shape 13"/>
+          <p:cNvPr id="16" name="Shape 14"/>
           <p:cNvSpPr/>
           <p:nvPr/>
         </p:nvSpPr>
@@ -5057,7 +5259,7 @@
       </p:sp>
       <p:sp>
         <p:nvSpPr>
-          <p:cNvPr id="16" name="Text 14"/>
+          <p:cNvPr id="17" name="Text 15"/>
           <p:cNvSpPr/>
           <p:nvPr/>
         </p:nvSpPr>
@@ -5093,7 +5295,7 @@
       </p:sp>
       <p:sp>
         <p:nvSpPr>
-          <p:cNvPr id="17" name="Text 15"/>
+          <p:cNvPr id="18" name="Text 16"/>
           <p:cNvSpPr/>
           <p:nvPr/>
         </p:nvSpPr>
@@ -5145,7 +5347,7 @@
       </p:sp>
       <p:sp>
         <p:nvSpPr>
-          <p:cNvPr id="18" name="Shape 16"/>
+          <p:cNvPr id="19" name="Shape 17"/>
           <p:cNvSpPr/>
           <p:nvPr/>
         </p:nvSpPr>
@@ -5170,7 +5372,7 @@
       </p:sp>
       <p:sp>
         <p:nvSpPr>
-          <p:cNvPr id="19" name="Text 17"/>
+          <p:cNvPr id="20" name="Text 18"/>
           <p:cNvSpPr/>
           <p:nvPr/>
         </p:nvSpPr>
@@ -5206,7 +5408,7 @@
       </p:sp>
       <p:sp>
         <p:nvSpPr>
-          <p:cNvPr id="20" name="Text 18"/>
+          <p:cNvPr id="21" name="Text 19"/>
           <p:cNvSpPr/>
           <p:nvPr/>
         </p:nvSpPr>
@@ -5258,7 +5460,7 @@
       </p:sp>
       <p:sp>
         <p:nvSpPr>
-          <p:cNvPr id="21" name="Shape 19"/>
+          <p:cNvPr id="22" name="Shape 20"/>
           <p:cNvSpPr/>
           <p:nvPr/>
         </p:nvSpPr>
@@ -5283,7 +5485,7 @@
       </p:sp>
       <p:sp>
         <p:nvSpPr>
-          <p:cNvPr id="22" name="Text 20"/>
+          <p:cNvPr id="23" name="Text 21"/>
           <p:cNvSpPr/>
           <p:nvPr/>
         </p:nvSpPr>
@@ -5319,7 +5521,7 @@
       </p:sp>
       <p:sp>
         <p:nvSpPr>
-          <p:cNvPr id="23" name="Text 21"/>
+          <p:cNvPr id="24" name="Text 22"/>
           <p:cNvSpPr/>
           <p:nvPr/>
         </p:nvSpPr>
@@ -5371,7 +5573,7 @@
       </p:sp>
       <p:sp>
         <p:nvSpPr>
-          <p:cNvPr id="24" name="Shape 22"/>
+          <p:cNvPr id="25" name="Shape 23"/>
           <p:cNvSpPr/>
           <p:nvPr/>
         </p:nvSpPr>
@@ -5396,7 +5598,7 @@
       </p:sp>
       <p:sp>
         <p:nvSpPr>
-          <p:cNvPr id="25" name="Text 23"/>
+          <p:cNvPr id="26" name="Text 24"/>
           <p:cNvSpPr/>
           <p:nvPr/>
         </p:nvSpPr>
@@ -5432,7 +5634,7 @@
       </p:sp>
       <p:sp>
         <p:nvSpPr>
-          <p:cNvPr id="26" name="Text 24"/>
+          <p:cNvPr id="27" name="Text 25"/>
           <p:cNvSpPr/>
           <p:nvPr/>
         </p:nvSpPr>
@@ -5484,7 +5686,7 @@
       </p:sp>
       <p:sp>
         <p:nvSpPr>
-          <p:cNvPr id="27" name="Shape 25"/>
+          <p:cNvPr id="28" name="Shape 26"/>
           <p:cNvSpPr/>
           <p:nvPr/>
         </p:nvSpPr>
@@ -5509,7 +5711,7 @@
       </p:sp>
       <p:sp>
         <p:nvSpPr>
-          <p:cNvPr id="28" name="Text 26"/>
+          <p:cNvPr id="29" name="Text 27"/>
           <p:cNvSpPr/>
           <p:nvPr/>
         </p:nvSpPr>
@@ -5545,7 +5747,7 @@
       </p:sp>
       <p:sp>
         <p:nvSpPr>
-          <p:cNvPr id="29" name="Text 27"/>
+          <p:cNvPr id="30" name="Text 28"/>
           <p:cNvSpPr/>
           <p:nvPr/>
         </p:nvSpPr>
@@ -5597,7 +5799,7 @@
       </p:sp>
       <p:sp>
         <p:nvSpPr>
-          <p:cNvPr id="30" name="Shape 28"/>
+          <p:cNvPr id="31" name="Shape 29"/>
           <p:cNvSpPr/>
           <p:nvPr/>
         </p:nvSpPr>
@@ -5622,7 +5824,7 @@
       </p:sp>
       <p:sp>
         <p:nvSpPr>
-          <p:cNvPr id="31" name="Text 29"/>
+          <p:cNvPr id="32" name="Text 30"/>
           <p:cNvSpPr/>
           <p:nvPr/>
         </p:nvSpPr>
@@ -5658,7 +5860,7 @@
       </p:sp>
       <p:sp>
         <p:nvSpPr>
-          <p:cNvPr id="32" name="Text 30"/>
+          <p:cNvPr id="33" name="Text 31"/>
           <p:cNvSpPr/>
           <p:nvPr/>
         </p:nvSpPr>
@@ -5710,7 +5912,7 @@
       </p:sp>
       <p:sp>
         <p:nvSpPr>
-          <p:cNvPr id="33" name="Shape 31"/>
+          <p:cNvPr id="34" name="Shape 32"/>
           <p:cNvSpPr/>
           <p:nvPr/>
         </p:nvSpPr>
@@ -5737,7 +5939,7 @@
       </p:sp>
       <p:sp>
         <p:nvSpPr>
-          <p:cNvPr id="34" name="Text 32"/>
+          <p:cNvPr id="35" name="Text 33"/>
           <p:cNvSpPr/>
           <p:nvPr/>
         </p:nvSpPr>
@@ -5775,7 +5977,7 @@
       </p:sp>
       <p:sp>
         <p:nvSpPr>
-          <p:cNvPr id="35" name="Text 33"/>
+          <p:cNvPr id="36" name="Text 34"/>
           <p:cNvSpPr/>
           <p:nvPr/>
         </p:nvSpPr>
@@ -5975,6 +6177,47 @@
         </p:nvSpPr>
         <p:spPr>
           <a:xfrm>
+            <a:off x="3749040" y="6254496"/>
+            <a:ext cx="7772400" cy="164592"/>
+          </a:xfrm>
+          <a:prstGeom prst="rect">
+            <a:avLst/>
+          </a:prstGeom>
+          <a:noFill/>
+          <a:ln/>
+        </p:spPr>
+        <p:txBody>
+          <a:bodyPr wrap="square" lIns="0" tIns="0" rIns="0" bIns="0" rtlCol="0" anchor="ctr">
+            <a:normAutofit/>
+          </a:bodyPr>
+          <a:lstStyle/>
+          <a:p>
+            <a:pPr algn="r" indent="0" marL="0">
+              <a:buNone/>
+            </a:pPr>
+            <a:r>
+              <a:rPr lang="en-US" sz="730" b="1" spc="35" kern="0" dirty="0">
+                <a:solidFill>
+                  <a:srgbClr val="5E6470"/>
+                </a:solidFill>
+                <a:latin typeface="Arial" pitchFamily="34" charset="0"/>
+                <a:ea typeface="Arial" pitchFamily="34" charset="-122"/>
+                <a:cs typeface="Arial" pitchFamily="34" charset="-120"/>
+              </a:rPr>
+              <a:t>DESIGN PATENT SIMILARITY WITH ARCFACE METRIC LEARNING  ·  HUI-CHING CHUANG  ·  YUEH-HENG WU</a:t>
+            </a:r>
+            <a:endParaRPr lang="en-US" sz="730" dirty="0"/>
+          </a:p>
+        </p:txBody>
+      </p:sp>
+      <p:sp>
+        <p:nvSpPr>
+          <p:cNvPr id="5" name="Text 3"/>
+          <p:cNvSpPr/>
+          <p:nvPr/>
+        </p:nvSpPr>
+        <p:spPr>
+          <a:xfrm>
             <a:off x="685800" y="1508760"/>
             <a:ext cx="4937760" cy="365760"/>
           </a:xfrm>
@@ -6005,7 +6248,7 @@
       </p:sp>
       <p:sp>
         <p:nvSpPr>
-          <p:cNvPr id="5" name="Text 3"/>
+          <p:cNvPr id="6" name="Text 4"/>
           <p:cNvSpPr/>
           <p:nvPr/>
         </p:nvSpPr>
@@ -6041,7 +6284,7 @@
       </p:sp>
       <p:sp>
         <p:nvSpPr>
-          <p:cNvPr id="6" name="Shape 4"/>
+          <p:cNvPr id="7" name="Shape 5"/>
           <p:cNvSpPr/>
           <p:nvPr/>
         </p:nvSpPr>
@@ -6068,7 +6311,7 @@
       </p:sp>
       <p:sp>
         <p:nvSpPr>
-          <p:cNvPr id="7" name="Text 5"/>
+          <p:cNvPr id="8" name="Text 6"/>
           <p:cNvSpPr/>
           <p:nvPr/>
         </p:nvSpPr>
@@ -6104,7 +6347,7 @@
       </p:sp>
       <p:sp>
         <p:nvSpPr>
-          <p:cNvPr id="8" name="Shape 6"/>
+          <p:cNvPr id="9" name="Shape 7"/>
           <p:cNvSpPr/>
           <p:nvPr/>
         </p:nvSpPr>
@@ -6129,7 +6372,7 @@
       </p:sp>
       <p:sp>
         <p:nvSpPr>
-          <p:cNvPr id="9" name="Text 7"/>
+          <p:cNvPr id="10" name="Text 8"/>
           <p:cNvSpPr/>
           <p:nvPr/>
         </p:nvSpPr>
@@ -6165,7 +6408,7 @@
       </p:sp>
       <p:sp>
         <p:nvSpPr>
-          <p:cNvPr id="10" name="Text 8"/>
+          <p:cNvPr id="11" name="Text 9"/>
           <p:cNvSpPr/>
           <p:nvPr/>
         </p:nvSpPr>
@@ -6201,7 +6444,7 @@
       </p:sp>
       <p:sp>
         <p:nvSpPr>
-          <p:cNvPr id="11" name="Shape 9"/>
+          <p:cNvPr id="12" name="Shape 10"/>
           <p:cNvSpPr/>
           <p:nvPr/>
         </p:nvSpPr>
@@ -6226,7 +6469,7 @@
       </p:sp>
       <p:sp>
         <p:nvSpPr>
-          <p:cNvPr id="12" name="Text 10"/>
+          <p:cNvPr id="13" name="Text 11"/>
           <p:cNvSpPr/>
           <p:nvPr/>
         </p:nvSpPr>
@@ -6262,7 +6505,7 @@
       </p:sp>
       <p:sp>
         <p:nvSpPr>
-          <p:cNvPr id="13" name="Text 11"/>
+          <p:cNvPr id="14" name="Text 12"/>
           <p:cNvSpPr/>
           <p:nvPr/>
         </p:nvSpPr>
@@ -6298,7 +6541,7 @@
       </p:sp>
       <p:sp>
         <p:nvSpPr>
-          <p:cNvPr id="14" name="Shape 12"/>
+          <p:cNvPr id="15" name="Shape 13"/>
           <p:cNvSpPr/>
           <p:nvPr/>
         </p:nvSpPr>
@@ -6325,7 +6568,7 @@
       </p:sp>
       <p:sp>
         <p:nvSpPr>
-          <p:cNvPr id="15" name="Text 13"/>
+          <p:cNvPr id="16" name="Text 14"/>
           <p:cNvSpPr/>
           <p:nvPr/>
         </p:nvSpPr>
@@ -6361,7 +6604,7 @@
       </p:sp>
       <p:sp>
         <p:nvSpPr>
-          <p:cNvPr id="16" name="Shape 14"/>
+          <p:cNvPr id="17" name="Shape 15"/>
           <p:cNvSpPr/>
           <p:nvPr/>
         </p:nvSpPr>
@@ -6386,7 +6629,7 @@
       </p:sp>
       <p:sp>
         <p:nvSpPr>
-          <p:cNvPr id="17" name="Text 15"/>
+          <p:cNvPr id="18" name="Text 16"/>
           <p:cNvSpPr/>
           <p:nvPr/>
         </p:nvSpPr>
@@ -6422,7 +6665,7 @@
       </p:sp>
       <p:sp>
         <p:nvSpPr>
-          <p:cNvPr id="18" name="Text 16"/>
+          <p:cNvPr id="19" name="Text 17"/>
           <p:cNvSpPr/>
           <p:nvPr/>
         </p:nvSpPr>
@@ -6458,7 +6701,7 @@
       </p:sp>
       <p:sp>
         <p:nvSpPr>
-          <p:cNvPr id="19" name="Shape 17"/>
+          <p:cNvPr id="20" name="Shape 18"/>
           <p:cNvSpPr/>
           <p:nvPr/>
         </p:nvSpPr>
@@ -6483,7 +6726,7 @@
       </p:sp>
       <p:sp>
         <p:nvSpPr>
-          <p:cNvPr id="20" name="Text 18"/>
+          <p:cNvPr id="21" name="Text 19"/>
           <p:cNvSpPr/>
           <p:nvPr/>
         </p:nvSpPr>
@@ -6519,7 +6762,7 @@
       </p:sp>
       <p:sp>
         <p:nvSpPr>
-          <p:cNvPr id="21" name="Text 19"/>
+          <p:cNvPr id="22" name="Text 20"/>
           <p:cNvSpPr/>
           <p:nvPr/>
         </p:nvSpPr>
@@ -6555,7 +6798,7 @@
       </p:sp>
       <p:sp>
         <p:nvSpPr>
-          <p:cNvPr id="22" name="Text 20"/>
+          <p:cNvPr id="23" name="Text 21"/>
           <p:cNvSpPr/>
           <p:nvPr/>
         </p:nvSpPr>
@@ -6591,7 +6834,7 @@
       </p:sp>
       <p:sp>
         <p:nvSpPr>
-          <p:cNvPr id="23" name="Text 21"/>
+          <p:cNvPr id="24" name="Text 22"/>
           <p:cNvSpPr/>
           <p:nvPr/>
         </p:nvSpPr>
@@ -6627,7 +6870,7 @@
       </p:sp>
       <p:sp>
         <p:nvSpPr>
-          <p:cNvPr id="24" name="Text 22"/>
+          <p:cNvPr id="25" name="Text 23"/>
           <p:cNvSpPr/>
           <p:nvPr/>
         </p:nvSpPr>
@@ -6663,7 +6906,7 @@
       </p:sp>
       <p:sp>
         <p:nvSpPr>
-          <p:cNvPr id="25" name="Text 23"/>
+          <p:cNvPr id="26" name="Text 24"/>
           <p:cNvSpPr/>
           <p:nvPr/>
         </p:nvSpPr>
@@ -6699,7 +6942,7 @@
       </p:sp>
       <p:sp>
         <p:nvSpPr>
-          <p:cNvPr id="26" name="Text 24"/>
+          <p:cNvPr id="27" name="Text 25"/>
           <p:cNvSpPr/>
           <p:nvPr/>
         </p:nvSpPr>
@@ -6891,9 +7134,50 @@
           </a:p>
         </p:txBody>
       </p:sp>
+      <p:sp>
+        <p:nvSpPr>
+          <p:cNvPr id="4" name="Text 2"/>
+          <p:cNvSpPr/>
+          <p:nvPr/>
+        </p:nvSpPr>
+        <p:spPr>
+          <a:xfrm>
+            <a:off x="3749040" y="6254496"/>
+            <a:ext cx="7772400" cy="164592"/>
+          </a:xfrm>
+          <a:prstGeom prst="rect">
+            <a:avLst/>
+          </a:prstGeom>
+          <a:noFill/>
+          <a:ln/>
+        </p:spPr>
+        <p:txBody>
+          <a:bodyPr wrap="square" lIns="0" tIns="0" rIns="0" bIns="0" rtlCol="0" anchor="ctr">
+            <a:normAutofit/>
+          </a:bodyPr>
+          <a:lstStyle/>
+          <a:p>
+            <a:pPr algn="r" indent="0" marL="0">
+              <a:buNone/>
+            </a:pPr>
+            <a:r>
+              <a:rPr lang="en-US" sz="730" b="1" spc="35" kern="0" dirty="0">
+                <a:solidFill>
+                  <a:srgbClr val="5E6470"/>
+                </a:solidFill>
+                <a:latin typeface="Arial" pitchFamily="34" charset="0"/>
+                <a:ea typeface="Arial" pitchFamily="34" charset="-122"/>
+                <a:cs typeface="Arial" pitchFamily="34" charset="-120"/>
+              </a:rPr>
+              <a:t>DESIGN PATENT SIMILARITY WITH ARCFACE METRIC LEARNING  ·  HUI-CHING CHUANG  ·  YUEH-HENG WU</a:t>
+            </a:r>
+            <a:endParaRPr lang="en-US" sz="730" dirty="0"/>
+          </a:p>
+        </p:txBody>
+      </p:sp>
       <p:pic>
         <p:nvPicPr>
-          <p:cNvPr id="4" name="Image 0" descr="C:\Dropbox\Apps\Overleaf\ACM Conference Proceedings Primary Article Template\figure\Hierarchical_Cosine_Distribution.png">    </p:cNvPr>
+          <p:cNvPr id="5" name="Image 0" descr="C:\Dropbox\Apps\Overleaf\ACM Conference Proceedings Primary Article Template\figure\Hierarchical_Cosine_Distribution.png">    </p:cNvPr>
           <p:cNvPicPr>
             <a:picLocks noChangeAspect="1"/>
           </p:cNvPicPr>
@@ -6917,7 +7201,7 @@
       </p:pic>
       <p:sp>
         <p:nvSpPr>
-          <p:cNvPr id="5" name="Shape 2"/>
+          <p:cNvPr id="6" name="Shape 3"/>
           <p:cNvSpPr/>
           <p:nvPr/>
         </p:nvSpPr>
@@ -6944,7 +7228,7 @@
       </p:sp>
       <p:sp>
         <p:nvSpPr>
-          <p:cNvPr id="6" name="Shape 3"/>
+          <p:cNvPr id="7" name="Shape 4"/>
           <p:cNvSpPr/>
           <p:nvPr/>
         </p:nvSpPr>
@@ -6971,7 +7255,7 @@
       </p:sp>
       <p:sp>
         <p:nvSpPr>
-          <p:cNvPr id="7" name="Shape 4"/>
+          <p:cNvPr id="8" name="Shape 5"/>
           <p:cNvSpPr/>
           <p:nvPr/>
         </p:nvSpPr>
@@ -6996,7 +7280,7 @@
       </p:sp>
       <p:sp>
         <p:nvSpPr>
-          <p:cNvPr id="8" name="Text 5"/>
+          <p:cNvPr id="9" name="Text 6"/>
           <p:cNvSpPr/>
           <p:nvPr/>
         </p:nvSpPr>
@@ -7034,7 +7318,7 @@
       </p:sp>
       <p:sp>
         <p:nvSpPr>
-          <p:cNvPr id="9" name="Text 6"/>
+          <p:cNvPr id="10" name="Text 7"/>
           <p:cNvSpPr/>
           <p:nvPr/>
         </p:nvSpPr>
@@ -7072,7 +7356,7 @@
       </p:sp>
       <p:sp>
         <p:nvSpPr>
-          <p:cNvPr id="10" name="Shape 7"/>
+          <p:cNvPr id="11" name="Shape 8"/>
           <p:cNvSpPr/>
           <p:nvPr/>
         </p:nvSpPr>
@@ -7099,7 +7383,7 @@
       </p:sp>
       <p:sp>
         <p:nvSpPr>
-          <p:cNvPr id="11" name="Shape 8"/>
+          <p:cNvPr id="12" name="Shape 9"/>
           <p:cNvSpPr/>
           <p:nvPr/>
         </p:nvSpPr>
@@ -7124,7 +7408,7 @@
       </p:sp>
       <p:sp>
         <p:nvSpPr>
-          <p:cNvPr id="12" name="Text 9"/>
+          <p:cNvPr id="13" name="Text 10"/>
           <p:cNvSpPr/>
           <p:nvPr/>
         </p:nvSpPr>
@@ -7162,7 +7446,7 @@
       </p:sp>
       <p:sp>
         <p:nvSpPr>
-          <p:cNvPr id="13" name="Text 10"/>
+          <p:cNvPr id="14" name="Text 11"/>
           <p:cNvSpPr/>
           <p:nvPr/>
         </p:nvSpPr>
@@ -7200,7 +7484,7 @@
       </p:sp>
       <p:sp>
         <p:nvSpPr>
-          <p:cNvPr id="14" name="Shape 11"/>
+          <p:cNvPr id="15" name="Shape 12"/>
           <p:cNvSpPr/>
           <p:nvPr/>
         </p:nvSpPr>
@@ -7227,7 +7511,7 @@
       </p:sp>
       <p:sp>
         <p:nvSpPr>
-          <p:cNvPr id="15" name="Shape 12"/>
+          <p:cNvPr id="16" name="Shape 13"/>
           <p:cNvSpPr/>
           <p:nvPr/>
         </p:nvSpPr>
@@ -7252,7 +7536,7 @@
       </p:sp>
       <p:sp>
         <p:nvSpPr>
-          <p:cNvPr id="16" name="Text 13"/>
+          <p:cNvPr id="17" name="Text 14"/>
           <p:cNvSpPr/>
           <p:nvPr/>
         </p:nvSpPr>
@@ -7290,7 +7574,7 @@
       </p:sp>
       <p:sp>
         <p:nvSpPr>
-          <p:cNvPr id="17" name="Text 14"/>
+          <p:cNvPr id="18" name="Text 15"/>
           <p:cNvSpPr/>
           <p:nvPr/>
         </p:nvSpPr>
@@ -7328,7 +7612,7 @@
       </p:sp>
       <p:sp>
         <p:nvSpPr>
-          <p:cNvPr id="18" name="Text 15"/>
+          <p:cNvPr id="19" name="Text 16"/>
           <p:cNvSpPr/>
           <p:nvPr/>
         </p:nvSpPr>
@@ -7520,9 +7804,50 @@
           </a:p>
         </p:txBody>
       </p:sp>
+      <p:sp>
+        <p:nvSpPr>
+          <p:cNvPr id="4" name="Text 2"/>
+          <p:cNvSpPr/>
+          <p:nvPr/>
+        </p:nvSpPr>
+        <p:spPr>
+          <a:xfrm>
+            <a:off x="3749040" y="6254496"/>
+            <a:ext cx="7772400" cy="164592"/>
+          </a:xfrm>
+          <a:prstGeom prst="rect">
+            <a:avLst/>
+          </a:prstGeom>
+          <a:noFill/>
+          <a:ln/>
+        </p:spPr>
+        <p:txBody>
+          <a:bodyPr wrap="square" lIns="0" tIns="0" rIns="0" bIns="0" rtlCol="0" anchor="ctr">
+            <a:normAutofit/>
+          </a:bodyPr>
+          <a:lstStyle/>
+          <a:p>
+            <a:pPr algn="r" indent="0" marL="0">
+              <a:buNone/>
+            </a:pPr>
+            <a:r>
+              <a:rPr lang="en-US" sz="730" b="1" spc="35" kern="0" dirty="0">
+                <a:solidFill>
+                  <a:srgbClr val="5E6470"/>
+                </a:solidFill>
+                <a:latin typeface="Arial" pitchFamily="34" charset="0"/>
+                <a:ea typeface="Arial" pitchFamily="34" charset="-122"/>
+                <a:cs typeface="Arial" pitchFamily="34" charset="-120"/>
+              </a:rPr>
+              <a:t>DESIGN PATENT SIMILARITY WITH ARCFACE METRIC LEARNING  ·  HUI-CHING CHUANG  ·  YUEH-HENG WU</a:t>
+            </a:r>
+            <a:endParaRPr lang="en-US" sz="730" dirty="0"/>
+          </a:p>
+        </p:txBody>
+      </p:sp>
       <p:pic>
         <p:nvPicPr>
-          <p:cNvPr id="4" name="Image 0" descr="C:\Dropbox\Apps\Overleaf\ACM Conference Proceedings Primary Article Template\figure\QE_Success_D0823510.png">    </p:cNvPr>
+          <p:cNvPr id="5" name="Image 0" descr="C:\Dropbox\Apps\Overleaf\ACM Conference Proceedings Primary Article Template\figure\QE_Success_D0823510.png">    </p:cNvPr>
           <p:cNvPicPr>
             <a:picLocks noChangeAspect="1"/>
           </p:cNvPicPr>
@@ -7546,7 +7871,7 @@
       </p:pic>
       <p:sp>
         <p:nvSpPr>
-          <p:cNvPr id="5" name="Shape 2"/>
+          <p:cNvPr id="6" name="Shape 3"/>
           <p:cNvSpPr/>
           <p:nvPr/>
         </p:nvSpPr>
@@ -7573,7 +7898,7 @@
       </p:sp>
       <p:sp>
         <p:nvSpPr>
-          <p:cNvPr id="6" name="Shape 3"/>
+          <p:cNvPr id="7" name="Shape 4"/>
           <p:cNvSpPr/>
           <p:nvPr/>
         </p:nvSpPr>
@@ -7600,7 +7925,7 @@
       </p:sp>
       <p:sp>
         <p:nvSpPr>
-          <p:cNvPr id="7" name="Shape 4"/>
+          <p:cNvPr id="8" name="Shape 5"/>
           <p:cNvSpPr/>
           <p:nvPr/>
         </p:nvSpPr>
@@ -7625,7 +7950,7 @@
       </p:sp>
       <p:sp>
         <p:nvSpPr>
-          <p:cNvPr id="8" name="Text 5"/>
+          <p:cNvPr id="9" name="Text 6"/>
           <p:cNvSpPr/>
           <p:nvPr/>
         </p:nvSpPr>
@@ -7663,7 +7988,7 @@
       </p:sp>
       <p:sp>
         <p:nvSpPr>
-          <p:cNvPr id="9" name="Text 6"/>
+          <p:cNvPr id="10" name="Text 7"/>
           <p:cNvSpPr/>
           <p:nvPr/>
         </p:nvSpPr>
@@ -7701,7 +8026,7 @@
       </p:sp>
       <p:sp>
         <p:nvSpPr>
-          <p:cNvPr id="10" name="Shape 7"/>
+          <p:cNvPr id="11" name="Shape 8"/>
           <p:cNvSpPr/>
           <p:nvPr/>
         </p:nvSpPr>
@@ -7728,7 +8053,7 @@
       </p:sp>
       <p:sp>
         <p:nvSpPr>
-          <p:cNvPr id="11" name="Shape 8"/>
+          <p:cNvPr id="12" name="Shape 9"/>
           <p:cNvSpPr/>
           <p:nvPr/>
         </p:nvSpPr>
@@ -7753,7 +8078,7 @@
       </p:sp>
       <p:sp>
         <p:nvSpPr>
-          <p:cNvPr id="12" name="Text 9"/>
+          <p:cNvPr id="13" name="Text 10"/>
           <p:cNvSpPr/>
           <p:nvPr/>
         </p:nvSpPr>
@@ -7791,7 +8116,7 @@
       </p:sp>
       <p:sp>
         <p:nvSpPr>
-          <p:cNvPr id="13" name="Text 10"/>
+          <p:cNvPr id="14" name="Text 11"/>
           <p:cNvSpPr/>
           <p:nvPr/>
         </p:nvSpPr>
@@ -7829,7 +8154,7 @@
       </p:sp>
       <p:sp>
         <p:nvSpPr>
-          <p:cNvPr id="14" name="Shape 11"/>
+          <p:cNvPr id="15" name="Shape 12"/>
           <p:cNvSpPr/>
           <p:nvPr/>
         </p:nvSpPr>
@@ -7856,7 +8181,7 @@
       </p:sp>
       <p:sp>
         <p:nvSpPr>
-          <p:cNvPr id="15" name="Shape 12"/>
+          <p:cNvPr id="16" name="Shape 13"/>
           <p:cNvSpPr/>
           <p:nvPr/>
         </p:nvSpPr>
@@ -7881,7 +8206,7 @@
       </p:sp>
       <p:sp>
         <p:nvSpPr>
-          <p:cNvPr id="16" name="Text 13"/>
+          <p:cNvPr id="17" name="Text 14"/>
           <p:cNvSpPr/>
           <p:nvPr/>
         </p:nvSpPr>
@@ -7919,7 +8244,7 @@
       </p:sp>
       <p:sp>
         <p:nvSpPr>
-          <p:cNvPr id="17" name="Text 14"/>
+          <p:cNvPr id="18" name="Text 15"/>
           <p:cNvSpPr/>
           <p:nvPr/>
         </p:nvSpPr>
@@ -7971,7 +8296,7 @@
       </p:sp>
       <p:sp>
         <p:nvSpPr>
-          <p:cNvPr id="18" name="Text 15"/>
+          <p:cNvPr id="19" name="Text 16"/>
           <p:cNvSpPr/>
           <p:nvPr/>
         </p:nvSpPr>
@@ -8165,7 +8490,48 @@
       </p:sp>
       <p:sp>
         <p:nvSpPr>
-          <p:cNvPr id="4" name="Shape 2"/>
+          <p:cNvPr id="4" name="Text 2"/>
+          <p:cNvSpPr/>
+          <p:nvPr/>
+        </p:nvSpPr>
+        <p:spPr>
+          <a:xfrm>
+            <a:off x="3749040" y="6254496"/>
+            <a:ext cx="7772400" cy="164592"/>
+          </a:xfrm>
+          <a:prstGeom prst="rect">
+            <a:avLst/>
+          </a:prstGeom>
+          <a:noFill/>
+          <a:ln/>
+        </p:spPr>
+        <p:txBody>
+          <a:bodyPr wrap="square" lIns="0" tIns="0" rIns="0" bIns="0" rtlCol="0" anchor="ctr">
+            <a:normAutofit/>
+          </a:bodyPr>
+          <a:lstStyle/>
+          <a:p>
+            <a:pPr algn="r" indent="0" marL="0">
+              <a:buNone/>
+            </a:pPr>
+            <a:r>
+              <a:rPr lang="en-US" sz="730" b="1" spc="35" kern="0" dirty="0">
+                <a:solidFill>
+                  <a:srgbClr val="5E6470"/>
+                </a:solidFill>
+                <a:latin typeface="Arial" pitchFamily="34" charset="0"/>
+                <a:ea typeface="Arial" pitchFamily="34" charset="-122"/>
+                <a:cs typeface="Arial" pitchFamily="34" charset="-120"/>
+              </a:rPr>
+              <a:t>DESIGN PATENT SIMILARITY WITH ARCFACE METRIC LEARNING  ·  HUI-CHING CHUANG  ·  YUEH-HENG WU</a:t>
+            </a:r>
+            <a:endParaRPr lang="en-US" sz="730" dirty="0"/>
+          </a:p>
+        </p:txBody>
+      </p:sp>
+      <p:sp>
+        <p:nvSpPr>
+          <p:cNvPr id="5" name="Shape 3"/>
           <p:cNvSpPr/>
           <p:nvPr/>
         </p:nvSpPr>
@@ -8192,7 +8558,7 @@
       </p:sp>
       <p:sp>
         <p:nvSpPr>
-          <p:cNvPr id="5" name="Shape 3"/>
+          <p:cNvPr id="6" name="Shape 4"/>
           <p:cNvSpPr/>
           <p:nvPr/>
         </p:nvSpPr>
@@ -8217,7 +8583,7 @@
       </p:sp>
       <p:sp>
         <p:nvSpPr>
-          <p:cNvPr id="6" name="Text 4"/>
+          <p:cNvPr id="7" name="Text 5"/>
           <p:cNvSpPr/>
           <p:nvPr/>
         </p:nvSpPr>
@@ -8255,7 +8621,7 @@
       </p:sp>
       <p:sp>
         <p:nvSpPr>
-          <p:cNvPr id="7" name="Text 5"/>
+          <p:cNvPr id="8" name="Text 6"/>
           <p:cNvSpPr/>
           <p:nvPr/>
         </p:nvSpPr>
@@ -8293,7 +8659,7 @@
       </p:sp>
       <p:sp>
         <p:nvSpPr>
-          <p:cNvPr id="8" name="Shape 6"/>
+          <p:cNvPr id="9" name="Shape 7"/>
           <p:cNvSpPr/>
           <p:nvPr/>
         </p:nvSpPr>
@@ -8320,7 +8686,7 @@
       </p:sp>
       <p:sp>
         <p:nvSpPr>
-          <p:cNvPr id="9" name="Shape 7"/>
+          <p:cNvPr id="10" name="Shape 8"/>
           <p:cNvSpPr/>
           <p:nvPr/>
         </p:nvSpPr>
@@ -8345,7 +8711,7 @@
       </p:sp>
       <p:sp>
         <p:nvSpPr>
-          <p:cNvPr id="10" name="Text 8"/>
+          <p:cNvPr id="11" name="Text 9"/>
           <p:cNvSpPr/>
           <p:nvPr/>
         </p:nvSpPr>
@@ -8383,7 +8749,7 @@
       </p:sp>
       <p:sp>
         <p:nvSpPr>
-          <p:cNvPr id="11" name="Text 9"/>
+          <p:cNvPr id="12" name="Text 10"/>
           <p:cNvSpPr/>
           <p:nvPr/>
         </p:nvSpPr>
@@ -8421,7 +8787,7 @@
       </p:sp>
       <p:sp>
         <p:nvSpPr>
-          <p:cNvPr id="12" name="Shape 10"/>
+          <p:cNvPr id="13" name="Shape 11"/>
           <p:cNvSpPr/>
           <p:nvPr/>
         </p:nvSpPr>
@@ -8448,7 +8814,7 @@
       </p:sp>
       <p:sp>
         <p:nvSpPr>
-          <p:cNvPr id="13" name="Shape 11"/>
+          <p:cNvPr id="14" name="Shape 12"/>
           <p:cNvSpPr/>
           <p:nvPr/>
         </p:nvSpPr>
@@ -8473,7 +8839,7 @@
       </p:sp>
       <p:sp>
         <p:nvSpPr>
-          <p:cNvPr id="14" name="Text 12"/>
+          <p:cNvPr id="15" name="Text 13"/>
           <p:cNvSpPr/>
           <p:nvPr/>
         </p:nvSpPr>
@@ -8511,7 +8877,7 @@
       </p:sp>
       <p:sp>
         <p:nvSpPr>
-          <p:cNvPr id="15" name="Text 13"/>
+          <p:cNvPr id="16" name="Text 14"/>
           <p:cNvSpPr/>
           <p:nvPr/>
         </p:nvSpPr>
@@ -8549,7 +8915,7 @@
       </p:sp>
       <p:sp>
         <p:nvSpPr>
-          <p:cNvPr id="16" name="Text 14"/>
+          <p:cNvPr id="17" name="Text 15"/>
           <p:cNvSpPr/>
           <p:nvPr/>
         </p:nvSpPr>
@@ -8587,7 +8953,7 @@
       </p:sp>
       <p:sp>
         <p:nvSpPr>
-          <p:cNvPr id="17" name="Text 15"/>
+          <p:cNvPr id="18" name="Text 16"/>
           <p:cNvSpPr/>
           <p:nvPr/>
         </p:nvSpPr>

</xml_diff>

<commit_message>
Add three retrieval plots to Design Patent slide 2
</commit_message>
<xml_diff>
--- a/files/DesignPatent_15min_Slides.pptx
+++ b/files/DesignPatent_15min_Slides.pptx
@@ -2156,7 +2156,7 @@
                 <a:ea typeface="Arial" pitchFamily="34" charset="-122"/>
                 <a:cs typeface="Arial" pitchFamily="34" charset="-120"/>
               </a:rPr>
-              <a:t>MOTIVATION</a:t>
+              <a:t>EXPERIMENTAL RESULTS</a:t>
             </a:r>
             <a:endParaRPr lang="en-US" sz="900" dirty="0"/>
           </a:p>
@@ -2197,7 +2197,7 @@
                 <a:ea typeface="Arial" pitchFamily="34" charset="-122"/>
                 <a:cs typeface="Arial" pitchFamily="34" charset="-120"/>
               </a:rPr>
-              <a:t>Prior-art search is a near-duplicate problem</a:t>
+              <a:t>Three retrieval examples show success and hard negatives</a:t>
             </a:r>
             <a:endParaRPr lang="en-US" sz="2800" dirty="0"/>
           </a:p>
@@ -2260,8 +2260,8 @@
         </p:blipFill>
         <p:spPr>
           <a:xfrm>
-            <a:off x="594360" y="1417320"/>
-            <a:ext cx="6903720" cy="4434840"/>
+            <a:off x="695647" y="1298448"/>
+            <a:ext cx="7524105" cy="1389888"/>
           </a:xfrm>
           <a:prstGeom prst="rect">
             <a:avLst/>
@@ -2276,8 +2276,8 @@
         </p:nvSpPr>
         <p:spPr>
           <a:xfrm>
-            <a:off x="594360" y="1417320"/>
-            <a:ext cx="6903720" cy="4434840"/>
+            <a:off x="695647" y="1298448"/>
+            <a:ext cx="7524105" cy="1389888"/>
           </a:xfrm>
           <a:prstGeom prst="rect">
             <a:avLst/>
@@ -2303,12 +2303,12 @@
         </p:nvSpPr>
         <p:spPr>
           <a:xfrm>
-            <a:off x="7818120" y="1417320"/>
-            <a:ext cx="3703320" cy="1280160"/>
+            <a:off x="8549640" y="1298448"/>
+            <a:ext cx="2971800" cy="1389888"/>
           </a:xfrm>
           <a:prstGeom prst="roundRect">
             <a:avLst>
-              <a:gd name="adj" fmla="val 3571"/>
+              <a:gd name="adj" fmla="val 3289"/>
             </a:avLst>
           </a:prstGeom>
           <a:solidFill>
@@ -2330,8 +2330,8 @@
         </p:nvSpPr>
         <p:spPr>
           <a:xfrm>
-            <a:off x="7818120" y="1417320"/>
-            <a:ext cx="64008" cy="1280160"/>
+            <a:off x="8549640" y="1298448"/>
+            <a:ext cx="64008" cy="1389888"/>
           </a:xfrm>
           <a:prstGeom prst="rect">
             <a:avLst/>
@@ -2355,8 +2355,8 @@
         </p:nvSpPr>
         <p:spPr>
           <a:xfrm>
-            <a:off x="8019288" y="1572768"/>
-            <a:ext cx="3374136" cy="274320"/>
+            <a:off x="8750808" y="1453896"/>
+            <a:ext cx="2642616" cy="274320"/>
           </a:xfrm>
           <a:prstGeom prst="rect">
             <a:avLst/>
@@ -2379,7 +2379,7 @@
                   <a:srgbClr val="111111"/>
                 </a:solidFill>
               </a:rPr>
-              <a:t>The retrieval challenge</a:t>
+              <a:t>Example 1 · exact recovery</a:t>
             </a:r>
             <a:endParaRPr lang="en-US" sz="1400" dirty="0"/>
           </a:p>
@@ -2393,8 +2393,8 @@
         </p:nvSpPr>
         <p:spPr>
           <a:xfrm>
-            <a:off x="8019288" y="1947672"/>
-            <a:ext cx="3374136" cy="621792"/>
+            <a:off x="8750808" y="1828800"/>
+            <a:ext cx="2642616" cy="731520"/>
           </a:xfrm>
           <a:prstGeom prst="rect">
             <a:avLst/>
@@ -2417,26 +2417,77 @@
                   <a:srgbClr val="5E6470"/>
                 </a:solidFill>
               </a:rPr>
-              <a:t>Multiple views can depict one design, while category similarity is too coarse for prior-art search.</a:t>
+              <a:t>Query D0807117: all five retrieved views share the query patent ID.</a:t>
             </a:r>
             <a:endParaRPr lang="en-US" sz="1150" dirty="0"/>
           </a:p>
         </p:txBody>
       </p:sp>
-      <p:sp>
-        <p:nvSpPr>
-          <p:cNvPr id="11" name="Shape 8"/>
-          <p:cNvSpPr/>
-          <p:nvPr/>
-        </p:nvSpPr>
-        <p:spPr>
-          <a:xfrm>
-            <a:off x="7818120" y="2926080"/>
-            <a:ext cx="3703320" cy="1280160"/>
+      <p:pic>
+        <p:nvPicPr>
+          <p:cNvPr id="11" name="Image 1" descr="C:\Dropbox\Apps\Overleaf\ACM Conference Proceedings Primary Article Template\figure\Compare_D0806975_313.png">    </p:cNvPr>
+          <p:cNvPicPr>
+            <a:picLocks noChangeAspect="1"/>
+          </p:cNvPicPr>
+          <p:nvPr/>
+        </p:nvPicPr>
+        <p:blipFill>
+          <a:blip r:embed="rId2"/>
+          <a:stretch>
+            <a:fillRect/>
+          </a:stretch>
+        </p:blipFill>
+        <p:spPr>
+          <a:xfrm>
+            <a:off x="690473" y="2889504"/>
+            <a:ext cx="7534455" cy="1389888"/>
+          </a:xfrm>
+          <a:prstGeom prst="rect">
+            <a:avLst/>
+          </a:prstGeom>
+        </p:spPr>
+      </p:pic>
+      <p:sp>
+        <p:nvSpPr>
+          <p:cNvPr id="12" name="Shape 8"/>
+          <p:cNvSpPr/>
+          <p:nvPr/>
+        </p:nvSpPr>
+        <p:spPr>
+          <a:xfrm>
+            <a:off x="690473" y="2889504"/>
+            <a:ext cx="7534455" cy="1389888"/>
+          </a:xfrm>
+          <a:prstGeom prst="rect">
+            <a:avLst/>
+          </a:prstGeom>
+          <a:solidFill>
+            <a:srgbClr val="FFFFFF">
+              <a:alpha val="0"/>
+            </a:srgbClr>
+          </a:solidFill>
+          <a:ln w="10160">
+            <a:solidFill>
+              <a:srgbClr val="C9CDD3"/>
+            </a:solidFill>
+            <a:prstDash val="solid"/>
+          </a:ln>
+        </p:spPr>
+      </p:sp>
+      <p:sp>
+        <p:nvSpPr>
+          <p:cNvPr id="13" name="Shape 9"/>
+          <p:cNvSpPr/>
+          <p:nvPr/>
+        </p:nvSpPr>
+        <p:spPr>
+          <a:xfrm>
+            <a:off x="8549640" y="2889504"/>
+            <a:ext cx="2971800" cy="1389888"/>
           </a:xfrm>
           <a:prstGeom prst="roundRect">
             <a:avLst>
-              <a:gd name="adj" fmla="val 3571"/>
+              <a:gd name="adj" fmla="val 3289"/>
             </a:avLst>
           </a:prstGeom>
           <a:solidFill>
@@ -2452,14 +2503,14 @@
       </p:sp>
       <p:sp>
         <p:nvSpPr>
-          <p:cNvPr id="12" name="Shape 9"/>
-          <p:cNvSpPr/>
-          <p:nvPr/>
-        </p:nvSpPr>
-        <p:spPr>
-          <a:xfrm>
-            <a:off x="7818120" y="2926080"/>
-            <a:ext cx="64008" cy="1280160"/>
+          <p:cNvPr id="14" name="Shape 10"/>
+          <p:cNvSpPr/>
+          <p:nvPr/>
+        </p:nvSpPr>
+        <p:spPr>
+          <a:xfrm>
+            <a:off x="8549640" y="2889504"/>
+            <a:ext cx="64008" cy="1389888"/>
           </a:xfrm>
           <a:prstGeom prst="rect">
             <a:avLst/>
@@ -2477,14 +2528,14 @@
       </p:sp>
       <p:sp>
         <p:nvSpPr>
-          <p:cNvPr id="13" name="Text 10"/>
-          <p:cNvSpPr/>
-          <p:nvPr/>
-        </p:nvSpPr>
-        <p:spPr>
-          <a:xfrm>
-            <a:off x="8019288" y="3081528"/>
-            <a:ext cx="3374136" cy="274320"/>
+          <p:cNvPr id="15" name="Text 11"/>
+          <p:cNvSpPr/>
+          <p:nvPr/>
+        </p:nvSpPr>
+        <p:spPr>
+          <a:xfrm>
+            <a:off x="8750808" y="3044952"/>
+            <a:ext cx="2642616" cy="274320"/>
           </a:xfrm>
           <a:prstGeom prst="rect">
             <a:avLst/>
@@ -2507,7 +2558,7 @@
                   <a:srgbClr val="111111"/>
                 </a:solidFill>
               </a:rPr>
-              <a:t>The research question</a:t>
+              <a:t>Example 2 · exact recovery</a:t>
             </a:r>
             <a:endParaRPr lang="en-US" sz="1400" dirty="0"/>
           </a:p>
@@ -2515,14 +2566,14 @@
       </p:sp>
       <p:sp>
         <p:nvSpPr>
-          <p:cNvPr id="14" name="Text 11"/>
-          <p:cNvSpPr/>
-          <p:nvPr/>
-        </p:nvSpPr>
-        <p:spPr>
-          <a:xfrm>
-            <a:off x="8019288" y="3456432"/>
-            <a:ext cx="3374136" cy="621792"/>
+          <p:cNvPr id="16" name="Text 12"/>
+          <p:cNvSpPr/>
+          <p:nvPr/>
+        </p:nvSpPr>
+        <p:spPr>
+          <a:xfrm>
+            <a:off x="8750808" y="3419856"/>
+            <a:ext cx="2642616" cy="731520"/>
           </a:xfrm>
           <a:prstGeom prst="rect">
             <a:avLst/>
@@ -2545,26 +2596,77 @@
                   <a:srgbClr val="5E6470"/>
                 </a:solidFill>
               </a:rPr>
-              <a:t>Can metric learning organize drawings around patent identity at national scale?</a:t>
+              <a:t>Query D0806975: all five retrieved views share the query patent ID.</a:t>
             </a:r>
             <a:endParaRPr lang="en-US" sz="1150" dirty="0"/>
           </a:p>
         </p:txBody>
       </p:sp>
-      <p:sp>
-        <p:nvSpPr>
-          <p:cNvPr id="15" name="Shape 12"/>
-          <p:cNvSpPr/>
-          <p:nvPr/>
-        </p:nvSpPr>
-        <p:spPr>
-          <a:xfrm>
-            <a:off x="7818120" y="4434840"/>
-            <a:ext cx="3703320" cy="1280160"/>
+      <p:pic>
+        <p:nvPicPr>
+          <p:cNvPr id="17" name="Image 2" descr="C:\Dropbox\Apps\Overleaf\ACM Conference Proceedings Primary Article Template\figure\Compare_D0808886_4704.png">    </p:cNvPr>
+          <p:cNvPicPr>
+            <a:picLocks noChangeAspect="1"/>
+          </p:cNvPicPr>
+          <p:nvPr/>
+        </p:nvPicPr>
+        <p:blipFill>
+          <a:blip r:embed="rId3"/>
+          <a:stretch>
+            <a:fillRect/>
+          </a:stretch>
+        </p:blipFill>
+        <p:spPr>
+          <a:xfrm>
+            <a:off x="741588" y="4480560"/>
+            <a:ext cx="7432223" cy="1389888"/>
+          </a:xfrm>
+          <a:prstGeom prst="rect">
+            <a:avLst/>
+          </a:prstGeom>
+        </p:spPr>
+      </p:pic>
+      <p:sp>
+        <p:nvSpPr>
+          <p:cNvPr id="18" name="Shape 13"/>
+          <p:cNvSpPr/>
+          <p:nvPr/>
+        </p:nvSpPr>
+        <p:spPr>
+          <a:xfrm>
+            <a:off x="741588" y="4480560"/>
+            <a:ext cx="7432223" cy="1389888"/>
+          </a:xfrm>
+          <a:prstGeom prst="rect">
+            <a:avLst/>
+          </a:prstGeom>
+          <a:solidFill>
+            <a:srgbClr val="FFFFFF">
+              <a:alpha val="0"/>
+            </a:srgbClr>
+          </a:solidFill>
+          <a:ln w="10160">
+            <a:solidFill>
+              <a:srgbClr val="C9CDD3"/>
+            </a:solidFill>
+            <a:prstDash val="solid"/>
+          </a:ln>
+        </p:spPr>
+      </p:sp>
+      <p:sp>
+        <p:nvSpPr>
+          <p:cNvPr id="19" name="Shape 14"/>
+          <p:cNvSpPr/>
+          <p:nvPr/>
+        </p:nvSpPr>
+        <p:spPr>
+          <a:xfrm>
+            <a:off x="8549640" y="4480560"/>
+            <a:ext cx="2971800" cy="1389888"/>
           </a:xfrm>
           <a:prstGeom prst="roundRect">
             <a:avLst>
-              <a:gd name="adj" fmla="val 3571"/>
+              <a:gd name="adj" fmla="val 3289"/>
             </a:avLst>
           </a:prstGeom>
           <a:solidFill>
@@ -2580,14 +2682,14 @@
       </p:sp>
       <p:sp>
         <p:nvSpPr>
-          <p:cNvPr id="16" name="Shape 13"/>
-          <p:cNvSpPr/>
-          <p:nvPr/>
-        </p:nvSpPr>
-        <p:spPr>
-          <a:xfrm>
-            <a:off x="7818120" y="4434840"/>
-            <a:ext cx="64008" cy="1280160"/>
+          <p:cNvPr id="20" name="Shape 15"/>
+          <p:cNvSpPr/>
+          <p:nvPr/>
+        </p:nvSpPr>
+        <p:spPr>
+          <a:xfrm>
+            <a:off x="8549640" y="4480560"/>
+            <a:ext cx="64008" cy="1389888"/>
           </a:xfrm>
           <a:prstGeom prst="rect">
             <a:avLst/>
@@ -2605,14 +2707,14 @@
       </p:sp>
       <p:sp>
         <p:nvSpPr>
-          <p:cNvPr id="17" name="Text 14"/>
-          <p:cNvSpPr/>
-          <p:nvPr/>
-        </p:nvSpPr>
-        <p:spPr>
-          <a:xfrm>
-            <a:off x="8019288" y="4590288"/>
-            <a:ext cx="3374136" cy="274320"/>
+          <p:cNvPr id="21" name="Text 16"/>
+          <p:cNvSpPr/>
+          <p:nvPr/>
+        </p:nvSpPr>
+        <p:spPr>
+          <a:xfrm>
+            <a:off x="8750808" y="4636008"/>
+            <a:ext cx="2642616" cy="274320"/>
           </a:xfrm>
           <a:prstGeom prst="rect">
             <a:avLst/>
@@ -2635,7 +2737,7 @@
                   <a:srgbClr val="111111"/>
                 </a:solidFill>
               </a:rPr>
-              <a:t>Experimental results</a:t>
+              <a:t>Example 3 · hard negative</a:t>
             </a:r>
             <a:endParaRPr lang="en-US" sz="1400" dirty="0"/>
           </a:p>
@@ -2643,14 +2745,14 @@
       </p:sp>
       <p:sp>
         <p:nvSpPr>
-          <p:cNvPr id="18" name="Text 15"/>
-          <p:cNvSpPr/>
-          <p:nvPr/>
-        </p:nvSpPr>
-        <p:spPr>
-          <a:xfrm>
-            <a:off x="8019288" y="4965192"/>
-            <a:ext cx="3374136" cy="621792"/>
+          <p:cNvPr id="22" name="Text 17"/>
+          <p:cNvSpPr/>
+          <p:nvPr/>
+        </p:nvSpPr>
+        <p:spPr>
+          <a:xfrm>
+            <a:off x="8750808" y="5010912"/>
+            <a:ext cx="2642616" cy="731520"/>
           </a:xfrm>
           <a:prstGeom prst="rect">
             <a:avLst/>
@@ -2673,7 +2775,7 @@
                   <a:srgbClr val="5E6470"/>
                 </a:solidFill>
               </a:rPr>
-              <a:t>Best mAP: 0.8193 Standard / 0.6493 Extended. Acc@1: 0.9312 / 0.8088.</a:t>
+              <a:t>Query D0808886: visually close panels rank highly despite different patent IDs.</a:t>
             </a:r>
             <a:endParaRPr lang="en-US" sz="1150" dirty="0"/>
           </a:p>
@@ -2681,7 +2783,7 @@
       </p:sp>
       <p:sp>
         <p:nvSpPr>
-          <p:cNvPr id="19" name="Text 16"/>
+          <p:cNvPr id="23" name="Text 18"/>
           <p:cNvSpPr/>
           <p:nvPr/>
         </p:nvSpPr>
@@ -2714,7 +2816,7 @@
                 <a:ea typeface="Arial" pitchFamily="34" charset="-122"/>
                 <a:cs typeface="Arial" pitchFamily="34" charset="-120"/>
               </a:rPr>
-              <a:t>Source: Design Patent Similarity with ArcFace Metric Learning</a:t>
+              <a:t>Extended Gallery qualitative retrieval results</a:t>
             </a:r>
             <a:endParaRPr lang="en-US" sz="750" dirty="0"/>
           </a:p>
@@ -7191,8 +7293,8 @@
         </p:blipFill>
         <p:spPr>
           <a:xfrm>
-            <a:off x="548640" y="1371600"/>
-            <a:ext cx="7452360" cy="4526280"/>
+            <a:off x="862237" y="1371600"/>
+            <a:ext cx="6825166" cy="4526280"/>
           </a:xfrm>
           <a:prstGeom prst="rect">
             <a:avLst/>
@@ -7207,8 +7309,8 @@
         </p:nvSpPr>
         <p:spPr>
           <a:xfrm>
-            <a:off x="548640" y="1371600"/>
-            <a:ext cx="7452360" cy="4526280"/>
+            <a:off x="862237" y="1371600"/>
+            <a:ext cx="6825166" cy="4526280"/>
           </a:xfrm>
           <a:prstGeom prst="rect">
             <a:avLst/>
@@ -7861,8 +7963,8 @@
         </p:blipFill>
         <p:spPr>
           <a:xfrm>
-            <a:off x="594360" y="1371600"/>
-            <a:ext cx="7726680" cy="4526280"/>
+            <a:off x="594360" y="2217234"/>
+            <a:ext cx="7726680" cy="2835011"/>
           </a:xfrm>
           <a:prstGeom prst="rect">
             <a:avLst/>
@@ -7877,8 +7979,8 @@
         </p:nvSpPr>
         <p:spPr>
           <a:xfrm>
-            <a:off x="594360" y="1371600"/>
-            <a:ext cx="7726680" cy="4526280"/>
+            <a:off x="594360" y="2217234"/>
+            <a:ext cx="7726680" cy="2835011"/>
           </a:xfrm>
           <a:prstGeom prst="rect">
             <a:avLst/>

</xml_diff>